<commit_message>
Update the lastest Pesentation
</commit_message>
<xml_diff>
--- a/IoMT_IDS_Presentation.pptx
+++ b/IoMT_IDS_Presentation.pptx
@@ -143,7 +143,7 @@
 <file path=ppt/revisionInfo.xml><?xml version="1.0" encoding="utf-8"?>
 <p1510:revInfo xmlns:a="http://schemas.openxmlformats.org/drawingml/2006/main" xmlns:r="http://schemas.openxmlformats.org/officeDocument/2006/relationships" xmlns:p1510="http://schemas.microsoft.com/office/powerpoint/2015/10/main">
   <p1510:revLst>
-    <p1510:client id="{14D8A4EF-6160-364B-9056-62E80023A26D}" v="57" dt="2026-03-22T19:05:50.759"/>
+    <p1510:client id="{14D8A4EF-6160-364B-9056-62E80023A26D}" v="59" dt="2026-03-22T19:27:25.402"/>
   </p1510:revLst>
 </p1510:revInfo>
 </file>
@@ -1070,31 +1070,7 @@
                 <a:ea typeface="+mn-ea"/>
                 <a:cs typeface="+mn-cs"/>
               </a:rPr>
-              <a:t>In this section, we evaluate the total latency of different methods. The latency is divided into three parts: </a:t>
-            </a:r>
-            <a:r>
-              <a:rPr lang="en-GB" sz="1200" kern="1200">
-                <a:solidFill>
-                  <a:schemeClr val="tx1"/>
-                </a:solidFill>
-                <a:effectLst/>
-                <a:latin typeface="+mn-lt"/>
-                <a:ea typeface="+mn-ea"/>
-                <a:cs typeface="+mn-cs"/>
-              </a:rPr>
-              <a:t>feature extraction, </a:t>
-            </a:r>
-            <a:r>
-              <a:rPr lang="en-GB" sz="1200" kern="1200" dirty="0">
-                <a:solidFill>
-                  <a:schemeClr val="tx1"/>
-                </a:solidFill>
-                <a:effectLst/>
-                <a:latin typeface="+mn-lt"/>
-                <a:ea typeface="+mn-ea"/>
-                <a:cs typeface="+mn-cs"/>
-              </a:rPr>
-              <a:t>network transmission, and inference.</a:t>
+              <a:t>In this section, we evaluate the total latency of different methods. The latency is divided into three parts: feature extraction, network transmission, and inference.</a:t>
             </a:r>
           </a:p>
           <a:p>
@@ -13631,9 +13607,9 @@
           </p:nvGrpSpPr>
           <p:grpSpPr>
             <a:xfrm>
-              <a:off x="5593947" y="4034164"/>
+              <a:off x="5593947" y="4034165"/>
               <a:ext cx="5493834" cy="556548"/>
-              <a:chOff x="5858107" y="1405055"/>
+              <a:chOff x="5858107" y="1405056"/>
               <a:chExt cx="5493834" cy="556548"/>
             </a:xfrm>
           </p:grpSpPr>
@@ -13651,7 +13627,7 @@
             </p:nvSpPr>
             <p:spPr>
               <a:xfrm>
-                <a:off x="5858107" y="1405055"/>
+                <a:off x="5858107" y="1405056"/>
                 <a:ext cx="5493834" cy="556548"/>
               </a:xfrm>
               <a:prstGeom prst="roundRect">
@@ -13735,7 +13711,7 @@
             <p:spPr>
               <a:xfrm flipH="1">
                 <a:off x="7376160" y="1452100"/>
-                <a:ext cx="3751620" cy="445220"/>
+                <a:ext cx="3751620" cy="445219"/>
               </a:xfrm>
               <a:prstGeom prst="rect">
                 <a:avLst/>
@@ -14865,6 +14841,68 @@
               </a:rPr>
               <a:t>Conclusion and Future Work</a:t>
             </a:r>
+          </a:p>
+        </p:txBody>
+      </p:sp>
+      <p:sp>
+        <p:nvSpPr>
+          <p:cNvPr id="3" name="Rectangle 2">
+            <a:extLst>
+              <a:ext uri="{FF2B5EF4-FFF2-40B4-BE49-F238E27FC236}">
+                <a16:creationId xmlns:a16="http://schemas.microsoft.com/office/drawing/2014/main" id="{52F01B0C-A6E5-C60E-7F3C-E1AED201B54A}"/>
+              </a:ext>
+            </a:extLst>
+          </p:cNvPr>
+          <p:cNvSpPr/>
+          <p:nvPr/>
+        </p:nvSpPr>
+        <p:spPr>
+          <a:xfrm>
+            <a:off x="3950208" y="4623528"/>
+            <a:ext cx="5193792" cy="1045327"/>
+          </a:xfrm>
+          <a:prstGeom prst="rect">
+            <a:avLst/>
+          </a:prstGeom>
+          <a:solidFill>
+            <a:schemeClr val="bg1"/>
+          </a:solidFill>
+          <a:ln>
+            <a:noFill/>
+          </a:ln>
+          <a:effectLst>
+            <a:glow rad="127000">
+              <a:schemeClr val="accent1">
+                <a:alpha val="0"/>
+              </a:schemeClr>
+            </a:glow>
+            <a:outerShdw blurRad="40000" dist="23000" dir="5400000" rotWithShape="0">
+              <a:schemeClr val="bg1">
+                <a:alpha val="35000"/>
+              </a:schemeClr>
+            </a:outerShdw>
+          </a:effectLst>
+        </p:spPr>
+        <p:style>
+          <a:lnRef idx="1">
+            <a:schemeClr val="accent1"/>
+          </a:lnRef>
+          <a:fillRef idx="3">
+            <a:schemeClr val="accent1"/>
+          </a:fillRef>
+          <a:effectRef idx="2">
+            <a:schemeClr val="accent1"/>
+          </a:effectRef>
+          <a:fontRef idx="minor">
+            <a:schemeClr val="lt1"/>
+          </a:fontRef>
+        </p:style>
+        <p:txBody>
+          <a:bodyPr rtlCol="0" anchor="ctr"/>
+          <a:lstStyle/>
+          <a:p>
+            <a:pPr algn="ctr"/>
+            <a:endParaRPr lang="en-US"/>
           </a:p>
         </p:txBody>
       </p:sp>
@@ -47848,7 +47886,7 @@
 </file>
 
 <file path=ppt/slides/slide9.xml><?xml version="1.0" encoding="utf-8"?>
-<p:sld xmlns:a="http://schemas.openxmlformats.org/drawingml/2006/main" xmlns:r="http://schemas.openxmlformats.org/officeDocument/2006/relationships" xmlns:p="http://schemas.openxmlformats.org/presentationml/2006/main">
+<p:sld xmlns:a="http://schemas.openxmlformats.org/drawingml/2006/main" xmlns:r="http://schemas.openxmlformats.org/officeDocument/2006/relationships" xmlns:p="http://schemas.openxmlformats.org/presentationml/2006/main" show="0">
   <p:cSld>
     <p:spTree>
       <p:nvGrpSpPr>

</xml_diff>